<commit_message>
Coeficiente de sacrificio con crecimiento del producto
</commit_message>
<xml_diff>
--- a/doc/Coeficiente de sacrificio.pptx
+++ b/doc/Coeficiente de sacrificio.pptx
@@ -5,16 +5,17 @@
     <p:sldMasterId id="2147483648" r:id="rId1"/>
   </p:sldMasterIdLst>
   <p:notesMasterIdLst>
-    <p:notesMasterId r:id="rId9"/>
+    <p:notesMasterId r:id="rId10"/>
   </p:notesMasterIdLst>
   <p:sldIdLst>
     <p:sldId id="273" r:id="rId2"/>
     <p:sldId id="262" r:id="rId3"/>
     <p:sldId id="274" r:id="rId4"/>
     <p:sldId id="263" r:id="rId5"/>
-    <p:sldId id="275" r:id="rId6"/>
-    <p:sldId id="276" r:id="rId7"/>
-    <p:sldId id="277" r:id="rId8"/>
+    <p:sldId id="277" r:id="rId6"/>
+    <p:sldId id="279" r:id="rId7"/>
+    <p:sldId id="278" r:id="rId8"/>
+    <p:sldId id="280" r:id="rId9"/>
   </p:sldIdLst>
   <p:sldSz cx="12192000" cy="6858000"/>
   <p:notesSz cx="6858000" cy="9144000"/>
@@ -209,7 +210,7 @@
           <a:p>
             <a:fld id="{E676F4CC-8EEC-4B7D-8690-FE5A2CF4A996}" type="datetimeFigureOut">
               <a:rPr lang="es-MX" smtClean="0"/>
-              <a:t>31/10/2025</a:t>
+              <a:t>06/11/2025</a:t>
             </a:fld>
             <a:endParaRPr lang="es-MX"/>
           </a:p>
@@ -804,7 +805,7 @@
           <a:p>
             <a:fld id="{D207358E-6E89-42EC-A39F-28F52F3BB1DC}" type="datetimeFigureOut">
               <a:rPr lang="es-GT" smtClean="0"/>
-              <a:t>31/10/2025</a:t>
+              <a:t>06/11/2025</a:t>
             </a:fld>
             <a:endParaRPr lang="es-GT"/>
           </a:p>
@@ -1004,7 +1005,7 @@
           <a:p>
             <a:fld id="{D207358E-6E89-42EC-A39F-28F52F3BB1DC}" type="datetimeFigureOut">
               <a:rPr lang="es-GT" smtClean="0"/>
-              <a:t>31/10/2025</a:t>
+              <a:t>06/11/2025</a:t>
             </a:fld>
             <a:endParaRPr lang="es-GT"/>
           </a:p>
@@ -1214,7 +1215,7 @@
           <a:p>
             <a:fld id="{D207358E-6E89-42EC-A39F-28F52F3BB1DC}" type="datetimeFigureOut">
               <a:rPr lang="es-GT" smtClean="0"/>
-              <a:t>31/10/2025</a:t>
+              <a:t>06/11/2025</a:t>
             </a:fld>
             <a:endParaRPr lang="es-GT"/>
           </a:p>
@@ -1414,7 +1415,7 @@
           <a:p>
             <a:fld id="{D207358E-6E89-42EC-A39F-28F52F3BB1DC}" type="datetimeFigureOut">
               <a:rPr lang="es-GT" smtClean="0"/>
-              <a:t>31/10/2025</a:t>
+              <a:t>06/11/2025</a:t>
             </a:fld>
             <a:endParaRPr lang="es-GT"/>
           </a:p>
@@ -1690,7 +1691,7 @@
           <a:p>
             <a:fld id="{D207358E-6E89-42EC-A39F-28F52F3BB1DC}" type="datetimeFigureOut">
               <a:rPr lang="es-GT" smtClean="0"/>
-              <a:t>31/10/2025</a:t>
+              <a:t>06/11/2025</a:t>
             </a:fld>
             <a:endParaRPr lang="es-GT"/>
           </a:p>
@@ -1958,7 +1959,7 @@
           <a:p>
             <a:fld id="{D207358E-6E89-42EC-A39F-28F52F3BB1DC}" type="datetimeFigureOut">
               <a:rPr lang="es-GT" smtClean="0"/>
-              <a:t>31/10/2025</a:t>
+              <a:t>06/11/2025</a:t>
             </a:fld>
             <a:endParaRPr lang="es-GT"/>
           </a:p>
@@ -2373,7 +2374,7 @@
           <a:p>
             <a:fld id="{D207358E-6E89-42EC-A39F-28F52F3BB1DC}" type="datetimeFigureOut">
               <a:rPr lang="es-GT" smtClean="0"/>
-              <a:t>31/10/2025</a:t>
+              <a:t>06/11/2025</a:t>
             </a:fld>
             <a:endParaRPr lang="es-GT"/>
           </a:p>
@@ -2515,7 +2516,7 @@
           <a:p>
             <a:fld id="{D207358E-6E89-42EC-A39F-28F52F3BB1DC}" type="datetimeFigureOut">
               <a:rPr lang="es-GT" smtClean="0"/>
-              <a:t>31/10/2025</a:t>
+              <a:t>06/11/2025</a:t>
             </a:fld>
             <a:endParaRPr lang="es-GT"/>
           </a:p>
@@ -2628,7 +2629,7 @@
           <a:p>
             <a:fld id="{D207358E-6E89-42EC-A39F-28F52F3BB1DC}" type="datetimeFigureOut">
               <a:rPr lang="es-GT" smtClean="0"/>
-              <a:t>31/10/2025</a:t>
+              <a:t>06/11/2025</a:t>
             </a:fld>
             <a:endParaRPr lang="es-GT"/>
           </a:p>
@@ -2941,7 +2942,7 @@
           <a:p>
             <a:fld id="{D207358E-6E89-42EC-A39F-28F52F3BB1DC}" type="datetimeFigureOut">
               <a:rPr lang="es-GT" smtClean="0"/>
-              <a:t>31/10/2025</a:t>
+              <a:t>06/11/2025</a:t>
             </a:fld>
             <a:endParaRPr lang="es-GT"/>
           </a:p>
@@ -3230,7 +3231,7 @@
           <a:p>
             <a:fld id="{D207358E-6E89-42EC-A39F-28F52F3BB1DC}" type="datetimeFigureOut">
               <a:rPr lang="es-GT" smtClean="0"/>
-              <a:t>31/10/2025</a:t>
+              <a:t>06/11/2025</a:t>
             </a:fld>
             <a:endParaRPr lang="es-GT"/>
           </a:p>
@@ -3473,7 +3474,7 @@
           <a:p>
             <a:fld id="{D207358E-6E89-42EC-A39F-28F52F3BB1DC}" type="datetimeFigureOut">
               <a:rPr lang="es-GT" smtClean="0"/>
-              <a:t>31/10/2025</a:t>
+              <a:t>06/11/2025</a:t>
             </a:fld>
             <a:endParaRPr lang="es-GT"/>
           </a:p>
@@ -6485,50 +6486,6 @@
           </a:p>
         </p:txBody>
       </p:sp>
-      <p:sp>
-        <p:nvSpPr>
-          <p:cNvPr id="10" name="CuadroTexto 9">
-            <a:extLst>
-              <a:ext uri="{FF2B5EF4-FFF2-40B4-BE49-F238E27FC236}">
-                <a16:creationId xmlns:a16="http://schemas.microsoft.com/office/drawing/2014/main" id="{DFCBF30B-8806-4C75-B5F8-64873EFCAEFB}"/>
-              </a:ext>
-            </a:extLst>
-          </p:cNvPr>
-          <p:cNvSpPr txBox="1"/>
-          <p:nvPr/>
-        </p:nvSpPr>
-        <p:spPr>
-          <a:xfrm>
-            <a:off x="2720341" y="208127"/>
-            <a:ext cx="9206188" cy="584775"/>
-          </a:xfrm>
-          <a:prstGeom prst="rect">
-            <a:avLst/>
-          </a:prstGeom>
-          <a:noFill/>
-        </p:spPr>
-        <p:txBody>
-          <a:bodyPr wrap="square" rtlCol="0">
-            <a:spAutoFit/>
-          </a:bodyPr>
-          <a:lstStyle/>
-          <a:p>
-            <a:r>
-              <a:rPr lang="es-MX" sz="3200" dirty="0">
-                <a:solidFill>
-                  <a:srgbClr val="FF7F00"/>
-                </a:solidFill>
-              </a:rPr>
-              <a:t>Propuesta utilizando inflación total</a:t>
-            </a:r>
-            <a:endParaRPr lang="es-GT" sz="2400" dirty="0">
-              <a:solidFill>
-                <a:srgbClr val="FF7F00"/>
-              </a:solidFill>
-            </a:endParaRPr>
-          </a:p>
-        </p:txBody>
-      </p:sp>
       <p:pic>
         <p:nvPicPr>
           <p:cNvPr id="5" name="Imagen 4">
@@ -6586,788 +6543,6 @@
         <p:cNvPr id="1" name="">
           <a:extLst>
             <a:ext uri="{FF2B5EF4-FFF2-40B4-BE49-F238E27FC236}">
-              <a16:creationId xmlns:a16="http://schemas.microsoft.com/office/drawing/2014/main" id="{54EC1E0F-3A03-65A1-EAA9-2150EE119E83}"/>
-            </a:ext>
-          </a:extLst>
-        </p:cNvPr>
-        <p:cNvGrpSpPr/>
-        <p:nvPr/>
-      </p:nvGrpSpPr>
-      <p:grpSpPr>
-        <a:xfrm>
-          <a:off x="0" y="0"/>
-          <a:ext cx="0" cy="0"/>
-          <a:chOff x="0" y="0"/>
-          <a:chExt cx="0" cy="0"/>
-        </a:xfrm>
-      </p:grpSpPr>
-      <p:sp>
-        <p:nvSpPr>
-          <p:cNvPr id="2" name="Título 1">
-            <a:extLst>
-              <a:ext uri="{FF2B5EF4-FFF2-40B4-BE49-F238E27FC236}">
-                <a16:creationId xmlns:a16="http://schemas.microsoft.com/office/drawing/2014/main" id="{FA1DD0DA-3E52-35FA-6008-F1DA6CD45944}"/>
-              </a:ext>
-            </a:extLst>
-          </p:cNvPr>
-          <p:cNvSpPr>
-            <a:spLocks noGrp="1"/>
-          </p:cNvSpPr>
-          <p:nvPr>
-            <p:ph type="ctrTitle"/>
-          </p:nvPr>
-        </p:nvSpPr>
-        <p:spPr/>
-        <p:txBody>
-          <a:bodyPr/>
-          <a:lstStyle/>
-          <a:p>
-            <a:endParaRPr lang="es-GT"/>
-          </a:p>
-        </p:txBody>
-      </p:sp>
-      <p:sp>
-        <p:nvSpPr>
-          <p:cNvPr id="3" name="Subtítulo 2">
-            <a:extLst>
-              <a:ext uri="{FF2B5EF4-FFF2-40B4-BE49-F238E27FC236}">
-                <a16:creationId xmlns:a16="http://schemas.microsoft.com/office/drawing/2014/main" id="{B1D0F4EF-2D98-0191-3B39-63B5D52D1DD5}"/>
-              </a:ext>
-            </a:extLst>
-          </p:cNvPr>
-          <p:cNvSpPr>
-            <a:spLocks noGrp="1"/>
-          </p:cNvSpPr>
-          <p:nvPr>
-            <p:ph type="subTitle" idx="1"/>
-          </p:nvPr>
-        </p:nvSpPr>
-        <p:spPr/>
-        <p:txBody>
-          <a:bodyPr/>
-          <a:lstStyle/>
-          <a:p>
-            <a:endParaRPr lang="es-GT"/>
-          </a:p>
-        </p:txBody>
-      </p:sp>
-      <p:pic>
-        <p:nvPicPr>
-          <p:cNvPr id="6" name="Imagen 5">
-            <a:extLst>
-              <a:ext uri="{FF2B5EF4-FFF2-40B4-BE49-F238E27FC236}">
-                <a16:creationId xmlns:a16="http://schemas.microsoft.com/office/drawing/2014/main" id="{2E0DEF24-BB80-82A7-8138-494FBF9BAC27}"/>
-              </a:ext>
-            </a:extLst>
-          </p:cNvPr>
-          <p:cNvPicPr>
-            <a:picLocks noChangeAspect="1"/>
-          </p:cNvPicPr>
-          <p:nvPr/>
-        </p:nvPicPr>
-        <p:blipFill>
-          <a:blip r:embed="rId2">
-            <a:extLst>
-              <a:ext uri="{28A0092B-C50C-407E-A947-70E740481C1C}">
-                <a14:useLocalDpi xmlns:a14="http://schemas.microsoft.com/office/drawing/2010/main" val="0"/>
-              </a:ext>
-            </a:extLst>
-          </a:blip>
-          <a:stretch>
-            <a:fillRect/>
-          </a:stretch>
-        </p:blipFill>
-        <p:spPr>
-          <a:xfrm>
-            <a:off x="0" y="0"/>
-            <a:ext cx="12192000" cy="6858000"/>
-          </a:xfrm>
-          <a:prstGeom prst="rect">
-            <a:avLst/>
-          </a:prstGeom>
-        </p:spPr>
-      </p:pic>
-      <p:sp>
-        <p:nvSpPr>
-          <p:cNvPr id="7" name="CuadroTexto 6">
-            <a:extLst>
-              <a:ext uri="{FF2B5EF4-FFF2-40B4-BE49-F238E27FC236}">
-                <a16:creationId xmlns:a16="http://schemas.microsoft.com/office/drawing/2014/main" id="{ADD180B3-394E-F5B7-5528-22C8C3FB6E23}"/>
-              </a:ext>
-            </a:extLst>
-          </p:cNvPr>
-          <p:cNvSpPr txBox="1"/>
-          <p:nvPr/>
-        </p:nvSpPr>
-        <p:spPr>
-          <a:xfrm>
-            <a:off x="165182" y="207239"/>
-            <a:ext cx="2281990" cy="523220"/>
-          </a:xfrm>
-          <a:prstGeom prst="rect">
-            <a:avLst/>
-          </a:prstGeom>
-          <a:noFill/>
-        </p:spPr>
-        <p:txBody>
-          <a:bodyPr wrap="square" rtlCol="0">
-            <a:spAutoFit/>
-          </a:bodyPr>
-          <a:lstStyle/>
-          <a:p>
-            <a:r>
-              <a:rPr lang="es-ES" sz="2800" b="1" dirty="0">
-                <a:latin typeface="Libre Franklin" pitchFamily="2" charset="0"/>
-              </a:rPr>
-              <a:t>Resultados</a:t>
-            </a:r>
-            <a:endParaRPr lang="es-GT" b="1" dirty="0">
-              <a:latin typeface="Libre Franklin" pitchFamily="2" charset="0"/>
-            </a:endParaRPr>
-          </a:p>
-        </p:txBody>
-      </p:sp>
-      <p:cxnSp>
-        <p:nvCxnSpPr>
-          <p:cNvPr id="8" name="Conector recto 7">
-            <a:extLst>
-              <a:ext uri="{FF2B5EF4-FFF2-40B4-BE49-F238E27FC236}">
-                <a16:creationId xmlns:a16="http://schemas.microsoft.com/office/drawing/2014/main" id="{16C81271-FEEB-0FD9-DC17-5AE6F8772B6E}"/>
-              </a:ext>
-            </a:extLst>
-          </p:cNvPr>
-          <p:cNvCxnSpPr>
-            <a:cxnSpLocks/>
-          </p:cNvCxnSpPr>
-          <p:nvPr/>
-        </p:nvCxnSpPr>
-        <p:spPr>
-          <a:xfrm>
-            <a:off x="265471" y="730459"/>
-            <a:ext cx="1908000" cy="0"/>
-          </a:xfrm>
-          <a:prstGeom prst="line">
-            <a:avLst/>
-          </a:prstGeom>
-          <a:ln w="38100">
-            <a:solidFill>
-              <a:srgbClr val="FF7F00"/>
-            </a:solidFill>
-          </a:ln>
-        </p:spPr>
-        <p:style>
-          <a:lnRef idx="1">
-            <a:schemeClr val="accent1"/>
-          </a:lnRef>
-          <a:fillRef idx="0">
-            <a:schemeClr val="accent1"/>
-          </a:fillRef>
-          <a:effectRef idx="0">
-            <a:schemeClr val="accent1"/>
-          </a:effectRef>
-          <a:fontRef idx="minor">
-            <a:schemeClr val="tx1"/>
-          </a:fontRef>
-        </p:style>
-      </p:cxnSp>
-      <p:sp>
-        <p:nvSpPr>
-          <p:cNvPr id="17" name="CuadroTexto 16">
-            <a:extLst>
-              <a:ext uri="{FF2B5EF4-FFF2-40B4-BE49-F238E27FC236}">
-                <a16:creationId xmlns:a16="http://schemas.microsoft.com/office/drawing/2014/main" id="{F6FAA530-1636-E419-6A74-6FC7195996EA}"/>
-              </a:ext>
-            </a:extLst>
-          </p:cNvPr>
-          <p:cNvSpPr txBox="1"/>
-          <p:nvPr/>
-        </p:nvSpPr>
-        <p:spPr>
-          <a:xfrm>
-            <a:off x="615293" y="4812916"/>
-            <a:ext cx="8996941" cy="646331"/>
-          </a:xfrm>
-          <a:prstGeom prst="rect">
-            <a:avLst/>
-          </a:prstGeom>
-          <a:noFill/>
-        </p:spPr>
-        <p:txBody>
-          <a:bodyPr wrap="square">
-            <a:spAutoFit/>
-          </a:bodyPr>
-          <a:lstStyle/>
-          <a:p>
-            <a:pPr algn="just"/>
-            <a:r>
-              <a:rPr lang="es-ES" sz="1800" dirty="0">
-                <a:latin typeface="Libre Franklin" pitchFamily="2" charset="0"/>
-              </a:rPr>
-              <a:t>La estimación del coeficiente de sacrificio es de </a:t>
-            </a:r>
-            <a:r>
-              <a:rPr lang="es-GT" sz="1800" b="0" i="0" u="none" strike="noStrike" baseline="0" dirty="0">
-                <a:solidFill>
-                  <a:srgbClr val="000000"/>
-                </a:solidFill>
-                <a:latin typeface="Libre Franklin" pitchFamily="2" charset="0"/>
-              </a:rPr>
-              <a:t>0.3052</a:t>
-            </a:r>
-            <a:r>
-              <a:rPr lang="es-ES" sz="1800" dirty="0">
-                <a:latin typeface="Libre Franklin" pitchFamily="2" charset="0"/>
-              </a:rPr>
-              <a:t> para un periodo de 5 años</a:t>
-            </a:r>
-          </a:p>
-          <a:p>
-            <a:pPr algn="just"/>
-            <a:r>
-              <a:rPr lang="es-ES" dirty="0">
-                <a:latin typeface="Libre Franklin" pitchFamily="2" charset="0"/>
-              </a:rPr>
-              <a:t>El intervalo de confianza al 90% dentro de la simulación es </a:t>
-            </a:r>
-            <a:r>
-              <a:rPr lang="es-MX" dirty="0">
-                <a:latin typeface="Libre Franklin" pitchFamily="2" charset="0"/>
-              </a:rPr>
-              <a:t>(-0.7660, 1.5775)</a:t>
-            </a:r>
-            <a:endParaRPr lang="es-ES" sz="1800" dirty="0">
-              <a:latin typeface="Libre Franklin" pitchFamily="2" charset="0"/>
-            </a:endParaRPr>
-          </a:p>
-        </p:txBody>
-      </p:sp>
-      <p:pic>
-        <p:nvPicPr>
-          <p:cNvPr id="5" name="Imagen 4">
-            <a:extLst>
-              <a:ext uri="{FF2B5EF4-FFF2-40B4-BE49-F238E27FC236}">
-                <a16:creationId xmlns:a16="http://schemas.microsoft.com/office/drawing/2014/main" id="{098C2661-EA20-4420-AF45-D6DEC69E8C4F}"/>
-              </a:ext>
-            </a:extLst>
-          </p:cNvPr>
-          <p:cNvPicPr>
-            <a:picLocks noChangeAspect="1"/>
-          </p:cNvPicPr>
-          <p:nvPr/>
-        </p:nvPicPr>
-        <p:blipFill rotWithShape="1">
-          <a:blip r:embed="rId3">
-            <a:extLst>
-              <a:ext uri="{28A0092B-C50C-407E-A947-70E740481C1C}">
-                <a14:useLocalDpi xmlns:a14="http://schemas.microsoft.com/office/drawing/2010/main" val="0"/>
-              </a:ext>
-            </a:extLst>
-          </a:blip>
-          <a:srcRect l="6598" r="5847"/>
-          <a:stretch/>
-        </p:blipFill>
-        <p:spPr>
-          <a:xfrm>
-            <a:off x="454538" y="870887"/>
-            <a:ext cx="4438000" cy="3801600"/>
-          </a:xfrm>
-          <a:prstGeom prst="rect">
-            <a:avLst/>
-          </a:prstGeom>
-        </p:spPr>
-      </p:pic>
-      <p:sp>
-        <p:nvSpPr>
-          <p:cNvPr id="15" name="CuadroTexto 14">
-            <a:extLst>
-              <a:ext uri="{FF2B5EF4-FFF2-40B4-BE49-F238E27FC236}">
-                <a16:creationId xmlns:a16="http://schemas.microsoft.com/office/drawing/2014/main" id="{3BD7E22F-2C32-4C24-B26C-B0EB80B5CB7F}"/>
-              </a:ext>
-            </a:extLst>
-          </p:cNvPr>
-          <p:cNvSpPr txBox="1"/>
-          <p:nvPr/>
-        </p:nvSpPr>
-        <p:spPr>
-          <a:xfrm>
-            <a:off x="2720341" y="208127"/>
-            <a:ext cx="9206188" cy="584775"/>
-          </a:xfrm>
-          <a:prstGeom prst="rect">
-            <a:avLst/>
-          </a:prstGeom>
-          <a:noFill/>
-        </p:spPr>
-        <p:txBody>
-          <a:bodyPr wrap="square" rtlCol="0">
-            <a:spAutoFit/>
-          </a:bodyPr>
-          <a:lstStyle/>
-          <a:p>
-            <a:r>
-              <a:rPr lang="es-MX" sz="3200" dirty="0">
-                <a:solidFill>
-                  <a:srgbClr val="FF7F00"/>
-                </a:solidFill>
-              </a:rPr>
-              <a:t>Propuesta utilizando inflación media ponderada</a:t>
-            </a:r>
-            <a:endParaRPr lang="es-GT" sz="2400" dirty="0">
-              <a:solidFill>
-                <a:srgbClr val="FF7F00"/>
-              </a:solidFill>
-            </a:endParaRPr>
-          </a:p>
-        </p:txBody>
-      </p:sp>
-      <p:pic>
-        <p:nvPicPr>
-          <p:cNvPr id="9" name="Imagen 8">
-            <a:extLst>
-              <a:ext uri="{FF2B5EF4-FFF2-40B4-BE49-F238E27FC236}">
-                <a16:creationId xmlns:a16="http://schemas.microsoft.com/office/drawing/2014/main" id="{839A2FED-2576-4BA9-8FEC-4A8C7250DF53}"/>
-              </a:ext>
-            </a:extLst>
-          </p:cNvPr>
-          <p:cNvPicPr>
-            <a:picLocks noChangeAspect="1"/>
-          </p:cNvPicPr>
-          <p:nvPr/>
-        </p:nvPicPr>
-        <p:blipFill>
-          <a:blip r:embed="rId4">
-            <a:extLst>
-              <a:ext uri="{28A0092B-C50C-407E-A947-70E740481C1C}">
-                <a14:useLocalDpi xmlns:a14="http://schemas.microsoft.com/office/drawing/2010/main" val="0"/>
-              </a:ext>
-            </a:extLst>
-          </a:blip>
-          <a:stretch>
-            <a:fillRect/>
-          </a:stretch>
-        </p:blipFill>
-        <p:spPr>
-          <a:xfrm>
-            <a:off x="5165707" y="713664"/>
-            <a:ext cx="5977801" cy="3985200"/>
-          </a:xfrm>
-          <a:prstGeom prst="rect">
-            <a:avLst/>
-          </a:prstGeom>
-        </p:spPr>
-      </p:pic>
-    </p:spTree>
-    <p:extLst>
-      <p:ext uri="{BB962C8B-B14F-4D97-AF65-F5344CB8AC3E}">
-        <p14:creationId xmlns:p14="http://schemas.microsoft.com/office/powerpoint/2010/main" val="1169721597"/>
-      </p:ext>
-    </p:extLst>
-  </p:cSld>
-  <p:clrMapOvr>
-    <a:masterClrMapping/>
-  </p:clrMapOvr>
-</p:sld>
-</file>
-
-<file path=ppt/slides/slide6.xml><?xml version="1.0" encoding="utf-8"?>
-<p:sld xmlns:a="http://schemas.openxmlformats.org/drawingml/2006/main" xmlns:r="http://schemas.openxmlformats.org/officeDocument/2006/relationships" xmlns:p="http://schemas.openxmlformats.org/presentationml/2006/main">
-  <p:cSld>
-    <p:spTree>
-      <p:nvGrpSpPr>
-        <p:cNvPr id="1" name="">
-          <a:extLst>
-            <a:ext uri="{FF2B5EF4-FFF2-40B4-BE49-F238E27FC236}">
-              <a16:creationId xmlns:a16="http://schemas.microsoft.com/office/drawing/2014/main" id="{54EC1E0F-3A03-65A1-EAA9-2150EE119E83}"/>
-            </a:ext>
-          </a:extLst>
-        </p:cNvPr>
-        <p:cNvGrpSpPr/>
-        <p:nvPr/>
-      </p:nvGrpSpPr>
-      <p:grpSpPr>
-        <a:xfrm>
-          <a:off x="0" y="0"/>
-          <a:ext cx="0" cy="0"/>
-          <a:chOff x="0" y="0"/>
-          <a:chExt cx="0" cy="0"/>
-        </a:xfrm>
-      </p:grpSpPr>
-      <p:sp>
-        <p:nvSpPr>
-          <p:cNvPr id="2" name="Título 1">
-            <a:extLst>
-              <a:ext uri="{FF2B5EF4-FFF2-40B4-BE49-F238E27FC236}">
-                <a16:creationId xmlns:a16="http://schemas.microsoft.com/office/drawing/2014/main" id="{FA1DD0DA-3E52-35FA-6008-F1DA6CD45944}"/>
-              </a:ext>
-            </a:extLst>
-          </p:cNvPr>
-          <p:cNvSpPr>
-            <a:spLocks noGrp="1"/>
-          </p:cNvSpPr>
-          <p:nvPr>
-            <p:ph type="ctrTitle"/>
-          </p:nvPr>
-        </p:nvSpPr>
-        <p:spPr/>
-        <p:txBody>
-          <a:bodyPr/>
-          <a:lstStyle/>
-          <a:p>
-            <a:endParaRPr lang="es-GT"/>
-          </a:p>
-        </p:txBody>
-      </p:sp>
-      <p:sp>
-        <p:nvSpPr>
-          <p:cNvPr id="3" name="Subtítulo 2">
-            <a:extLst>
-              <a:ext uri="{FF2B5EF4-FFF2-40B4-BE49-F238E27FC236}">
-                <a16:creationId xmlns:a16="http://schemas.microsoft.com/office/drawing/2014/main" id="{B1D0F4EF-2D98-0191-3B39-63B5D52D1DD5}"/>
-              </a:ext>
-            </a:extLst>
-          </p:cNvPr>
-          <p:cNvSpPr>
-            <a:spLocks noGrp="1"/>
-          </p:cNvSpPr>
-          <p:nvPr>
-            <p:ph type="subTitle" idx="1"/>
-          </p:nvPr>
-        </p:nvSpPr>
-        <p:spPr/>
-        <p:txBody>
-          <a:bodyPr/>
-          <a:lstStyle/>
-          <a:p>
-            <a:endParaRPr lang="es-GT"/>
-          </a:p>
-        </p:txBody>
-      </p:sp>
-      <p:pic>
-        <p:nvPicPr>
-          <p:cNvPr id="6" name="Imagen 5">
-            <a:extLst>
-              <a:ext uri="{FF2B5EF4-FFF2-40B4-BE49-F238E27FC236}">
-                <a16:creationId xmlns:a16="http://schemas.microsoft.com/office/drawing/2014/main" id="{2E0DEF24-BB80-82A7-8138-494FBF9BAC27}"/>
-              </a:ext>
-            </a:extLst>
-          </p:cNvPr>
-          <p:cNvPicPr>
-            <a:picLocks noChangeAspect="1"/>
-          </p:cNvPicPr>
-          <p:nvPr/>
-        </p:nvPicPr>
-        <p:blipFill>
-          <a:blip r:embed="rId2">
-            <a:extLst>
-              <a:ext uri="{28A0092B-C50C-407E-A947-70E740481C1C}">
-                <a14:useLocalDpi xmlns:a14="http://schemas.microsoft.com/office/drawing/2010/main" val="0"/>
-              </a:ext>
-            </a:extLst>
-          </a:blip>
-          <a:stretch>
-            <a:fillRect/>
-          </a:stretch>
-        </p:blipFill>
-        <p:spPr>
-          <a:xfrm>
-            <a:off x="0" y="0"/>
-            <a:ext cx="12192000" cy="6858000"/>
-          </a:xfrm>
-          <a:prstGeom prst="rect">
-            <a:avLst/>
-          </a:prstGeom>
-        </p:spPr>
-      </p:pic>
-      <p:sp>
-        <p:nvSpPr>
-          <p:cNvPr id="7" name="CuadroTexto 6">
-            <a:extLst>
-              <a:ext uri="{FF2B5EF4-FFF2-40B4-BE49-F238E27FC236}">
-                <a16:creationId xmlns:a16="http://schemas.microsoft.com/office/drawing/2014/main" id="{ADD180B3-394E-F5B7-5528-22C8C3FB6E23}"/>
-              </a:ext>
-            </a:extLst>
-          </p:cNvPr>
-          <p:cNvSpPr txBox="1"/>
-          <p:nvPr/>
-        </p:nvSpPr>
-        <p:spPr>
-          <a:xfrm>
-            <a:off x="165182" y="207239"/>
-            <a:ext cx="2281990" cy="523220"/>
-          </a:xfrm>
-          <a:prstGeom prst="rect">
-            <a:avLst/>
-          </a:prstGeom>
-          <a:noFill/>
-        </p:spPr>
-        <p:txBody>
-          <a:bodyPr wrap="square" rtlCol="0">
-            <a:spAutoFit/>
-          </a:bodyPr>
-          <a:lstStyle/>
-          <a:p>
-            <a:r>
-              <a:rPr lang="es-ES" sz="2800" b="1" dirty="0">
-                <a:latin typeface="Libre Franklin" pitchFamily="2" charset="0"/>
-              </a:rPr>
-              <a:t>Resultados</a:t>
-            </a:r>
-            <a:endParaRPr lang="es-GT" b="1" dirty="0">
-              <a:latin typeface="Libre Franklin" pitchFamily="2" charset="0"/>
-            </a:endParaRPr>
-          </a:p>
-        </p:txBody>
-      </p:sp>
-      <p:cxnSp>
-        <p:nvCxnSpPr>
-          <p:cNvPr id="8" name="Conector recto 7">
-            <a:extLst>
-              <a:ext uri="{FF2B5EF4-FFF2-40B4-BE49-F238E27FC236}">
-                <a16:creationId xmlns:a16="http://schemas.microsoft.com/office/drawing/2014/main" id="{16C81271-FEEB-0FD9-DC17-5AE6F8772B6E}"/>
-              </a:ext>
-            </a:extLst>
-          </p:cNvPr>
-          <p:cNvCxnSpPr>
-            <a:cxnSpLocks/>
-          </p:cNvCxnSpPr>
-          <p:nvPr/>
-        </p:nvCxnSpPr>
-        <p:spPr>
-          <a:xfrm>
-            <a:off x="265471" y="730459"/>
-            <a:ext cx="1908000" cy="0"/>
-          </a:xfrm>
-          <a:prstGeom prst="line">
-            <a:avLst/>
-          </a:prstGeom>
-          <a:ln w="38100">
-            <a:solidFill>
-              <a:srgbClr val="FF7F00"/>
-            </a:solidFill>
-          </a:ln>
-        </p:spPr>
-        <p:style>
-          <a:lnRef idx="1">
-            <a:schemeClr val="accent1"/>
-          </a:lnRef>
-          <a:fillRef idx="0">
-            <a:schemeClr val="accent1"/>
-          </a:fillRef>
-          <a:effectRef idx="0">
-            <a:schemeClr val="accent1"/>
-          </a:effectRef>
-          <a:fontRef idx="minor">
-            <a:schemeClr val="tx1"/>
-          </a:fontRef>
-        </p:style>
-      </p:cxnSp>
-      <p:sp>
-        <p:nvSpPr>
-          <p:cNvPr id="17" name="CuadroTexto 16">
-            <a:extLst>
-              <a:ext uri="{FF2B5EF4-FFF2-40B4-BE49-F238E27FC236}">
-                <a16:creationId xmlns:a16="http://schemas.microsoft.com/office/drawing/2014/main" id="{F6FAA530-1636-E419-6A74-6FC7195996EA}"/>
-              </a:ext>
-            </a:extLst>
-          </p:cNvPr>
-          <p:cNvSpPr txBox="1"/>
-          <p:nvPr/>
-        </p:nvSpPr>
-        <p:spPr>
-          <a:xfrm>
-            <a:off x="615293" y="4812916"/>
-            <a:ext cx="8996941" cy="646331"/>
-          </a:xfrm>
-          <a:prstGeom prst="rect">
-            <a:avLst/>
-          </a:prstGeom>
-          <a:noFill/>
-        </p:spPr>
-        <p:txBody>
-          <a:bodyPr wrap="square">
-            <a:spAutoFit/>
-          </a:bodyPr>
-          <a:lstStyle/>
-          <a:p>
-            <a:pPr algn="just"/>
-            <a:r>
-              <a:rPr lang="es-ES" sz="1800" dirty="0">
-                <a:latin typeface="Libre Franklin" pitchFamily="2" charset="0"/>
-              </a:rPr>
-              <a:t>La estimación del coeficiente de sacrificio es de </a:t>
-            </a:r>
-            <a:r>
-              <a:rPr lang="es-GT" sz="1800" b="0" i="0" u="none" strike="noStrike" baseline="0" dirty="0">
-                <a:solidFill>
-                  <a:srgbClr val="000000"/>
-                </a:solidFill>
-                <a:latin typeface="Libre Franklin" pitchFamily="2" charset="0"/>
-              </a:rPr>
-              <a:t>0.4757</a:t>
-            </a:r>
-            <a:r>
-              <a:rPr lang="es-ES" sz="1800" dirty="0">
-                <a:latin typeface="Libre Franklin" pitchFamily="2" charset="0"/>
-              </a:rPr>
-              <a:t> para un periodo de 5 años</a:t>
-            </a:r>
-          </a:p>
-          <a:p>
-            <a:pPr algn="just"/>
-            <a:r>
-              <a:rPr lang="es-ES" dirty="0">
-                <a:latin typeface="Libre Franklin" pitchFamily="2" charset="0"/>
-              </a:rPr>
-              <a:t>El intervalo de confianza al 90% dentro de la simulación es </a:t>
-            </a:r>
-            <a:r>
-              <a:rPr lang="es-MX" dirty="0">
-                <a:latin typeface="Libre Franklin" pitchFamily="2" charset="0"/>
-              </a:rPr>
-              <a:t>(-0.6677, 2.1664)</a:t>
-            </a:r>
-            <a:endParaRPr lang="es-ES" sz="1800" dirty="0">
-              <a:latin typeface="Libre Franklin" pitchFamily="2" charset="0"/>
-            </a:endParaRPr>
-          </a:p>
-        </p:txBody>
-      </p:sp>
-      <p:pic>
-        <p:nvPicPr>
-          <p:cNvPr id="9" name="Imagen 8">
-            <a:extLst>
-              <a:ext uri="{FF2B5EF4-FFF2-40B4-BE49-F238E27FC236}">
-                <a16:creationId xmlns:a16="http://schemas.microsoft.com/office/drawing/2014/main" id="{274C5109-24F7-4D90-8C35-A8BD55EC3B70}"/>
-              </a:ext>
-            </a:extLst>
-          </p:cNvPr>
-          <p:cNvPicPr>
-            <a:picLocks noChangeAspect="1"/>
-          </p:cNvPicPr>
-          <p:nvPr/>
-        </p:nvPicPr>
-        <p:blipFill rotWithShape="1">
-          <a:blip r:embed="rId3">
-            <a:extLst>
-              <a:ext uri="{28A0092B-C50C-407E-A947-70E740481C1C}">
-                <a14:useLocalDpi xmlns:a14="http://schemas.microsoft.com/office/drawing/2010/main" val="0"/>
-              </a:ext>
-            </a:extLst>
-          </a:blip>
-          <a:srcRect l="6598" r="5731"/>
-          <a:stretch/>
-        </p:blipFill>
-        <p:spPr>
-          <a:xfrm>
-            <a:off x="615293" y="917659"/>
-            <a:ext cx="4443849" cy="3801600"/>
-          </a:xfrm>
-          <a:prstGeom prst="rect">
-            <a:avLst/>
-          </a:prstGeom>
-        </p:spPr>
-      </p:pic>
-      <p:sp>
-        <p:nvSpPr>
-          <p:cNvPr id="13" name="CuadroTexto 12">
-            <a:extLst>
-              <a:ext uri="{FF2B5EF4-FFF2-40B4-BE49-F238E27FC236}">
-                <a16:creationId xmlns:a16="http://schemas.microsoft.com/office/drawing/2014/main" id="{7DA77732-FF7A-4170-825B-9411D25E54A5}"/>
-              </a:ext>
-            </a:extLst>
-          </p:cNvPr>
-          <p:cNvSpPr txBox="1"/>
-          <p:nvPr/>
-        </p:nvSpPr>
-        <p:spPr>
-          <a:xfrm>
-            <a:off x="2720341" y="208127"/>
-            <a:ext cx="9206188" cy="584775"/>
-          </a:xfrm>
-          <a:prstGeom prst="rect">
-            <a:avLst/>
-          </a:prstGeom>
-          <a:noFill/>
-        </p:spPr>
-        <p:txBody>
-          <a:bodyPr wrap="square" rtlCol="0">
-            <a:spAutoFit/>
-          </a:bodyPr>
-          <a:lstStyle/>
-          <a:p>
-            <a:r>
-              <a:rPr lang="es-MX" sz="3200" dirty="0">
-                <a:solidFill>
-                  <a:srgbClr val="FF7F00"/>
-                </a:solidFill>
-              </a:rPr>
-              <a:t>Propuesta utilizando inflación subyacente óptima MSE</a:t>
-            </a:r>
-            <a:endParaRPr lang="es-GT" sz="2400" dirty="0">
-              <a:solidFill>
-                <a:srgbClr val="FF7F00"/>
-              </a:solidFill>
-            </a:endParaRPr>
-          </a:p>
-        </p:txBody>
-      </p:sp>
-      <p:pic>
-        <p:nvPicPr>
-          <p:cNvPr id="5" name="Imagen 4">
-            <a:extLst>
-              <a:ext uri="{FF2B5EF4-FFF2-40B4-BE49-F238E27FC236}">
-                <a16:creationId xmlns:a16="http://schemas.microsoft.com/office/drawing/2014/main" id="{CED7A16D-76B8-4A99-98EB-56B208A88FA3}"/>
-              </a:ext>
-            </a:extLst>
-          </p:cNvPr>
-          <p:cNvPicPr>
-            <a:picLocks noChangeAspect="1"/>
-          </p:cNvPicPr>
-          <p:nvPr/>
-        </p:nvPicPr>
-        <p:blipFill>
-          <a:blip r:embed="rId4">
-            <a:extLst>
-              <a:ext uri="{28A0092B-C50C-407E-A947-70E740481C1C}">
-                <a14:useLocalDpi xmlns:a14="http://schemas.microsoft.com/office/drawing/2010/main" val="0"/>
-              </a:ext>
-            </a:extLst>
-          </a:blip>
-          <a:stretch>
-            <a:fillRect/>
-          </a:stretch>
-        </p:blipFill>
-        <p:spPr>
-          <a:xfrm>
-            <a:off x="5237070" y="744684"/>
-            <a:ext cx="5977800" cy="3985200"/>
-          </a:xfrm>
-          <a:prstGeom prst="rect">
-            <a:avLst/>
-          </a:prstGeom>
-        </p:spPr>
-      </p:pic>
-    </p:spTree>
-    <p:extLst>
-      <p:ext uri="{BB962C8B-B14F-4D97-AF65-F5344CB8AC3E}">
-        <p14:creationId xmlns:p14="http://schemas.microsoft.com/office/powerpoint/2010/main" val="4241189089"/>
-      </p:ext>
-    </p:extLst>
-  </p:cSld>
-  <p:clrMapOvr>
-    <a:masterClrMapping/>
-  </p:clrMapOvr>
-</p:sld>
-</file>
-
-<file path=ppt/slides/slide7.xml><?xml version="1.0" encoding="utf-8"?>
-<p:sld xmlns:a="http://schemas.openxmlformats.org/drawingml/2006/main" xmlns:r="http://schemas.openxmlformats.org/officeDocument/2006/relationships" xmlns:p="http://schemas.openxmlformats.org/presentationml/2006/main">
-  <p:cSld>
-    <p:spTree>
-      <p:nvGrpSpPr>
-        <p:cNvPr id="1" name="">
-          <a:extLst>
-            <a:ext uri="{FF2B5EF4-FFF2-40B4-BE49-F238E27FC236}">
               <a16:creationId xmlns:a16="http://schemas.microsoft.com/office/drawing/2014/main" id="{8F6E9594-4557-6789-7591-C3FE85A6E671}"/>
             </a:ext>
           </a:extLst>
@@ -7647,6 +6822,652 @@
     <p:extLst>
       <p:ext uri="{BB962C8B-B14F-4D97-AF65-F5344CB8AC3E}">
         <p14:creationId xmlns:p14="http://schemas.microsoft.com/office/powerpoint/2010/main" val="2885111297"/>
+      </p:ext>
+    </p:extLst>
+  </p:cSld>
+  <p:clrMapOvr>
+    <a:masterClrMapping/>
+  </p:clrMapOvr>
+</p:sld>
+</file>
+
+<file path=ppt/slides/slide6.xml><?xml version="1.0" encoding="utf-8"?>
+<p:sld xmlns:a="http://schemas.openxmlformats.org/drawingml/2006/main" xmlns:r="http://schemas.openxmlformats.org/officeDocument/2006/relationships" xmlns:p="http://schemas.openxmlformats.org/presentationml/2006/main">
+  <p:cSld>
+    <p:spTree>
+      <p:nvGrpSpPr>
+        <p:cNvPr id="1" name="">
+          <a:extLst>
+            <a:ext uri="{FF2B5EF4-FFF2-40B4-BE49-F238E27FC236}">
+              <a16:creationId xmlns:a16="http://schemas.microsoft.com/office/drawing/2014/main" id="{54EC1E0F-3A03-65A1-EAA9-2150EE119E83}"/>
+            </a:ext>
+          </a:extLst>
+        </p:cNvPr>
+        <p:cNvGrpSpPr/>
+        <p:nvPr/>
+      </p:nvGrpSpPr>
+      <p:grpSpPr>
+        <a:xfrm>
+          <a:off x="0" y="0"/>
+          <a:ext cx="0" cy="0"/>
+          <a:chOff x="0" y="0"/>
+          <a:chExt cx="0" cy="0"/>
+        </a:xfrm>
+      </p:grpSpPr>
+      <p:sp>
+        <p:nvSpPr>
+          <p:cNvPr id="7" name="CuadroTexto 6">
+            <a:extLst>
+              <a:ext uri="{FF2B5EF4-FFF2-40B4-BE49-F238E27FC236}">
+                <a16:creationId xmlns:a16="http://schemas.microsoft.com/office/drawing/2014/main" id="{ADD180B3-394E-F5B7-5528-22C8C3FB6E23}"/>
+              </a:ext>
+            </a:extLst>
+          </p:cNvPr>
+          <p:cNvSpPr txBox="1"/>
+          <p:nvPr/>
+        </p:nvSpPr>
+        <p:spPr>
+          <a:xfrm>
+            <a:off x="165182" y="207239"/>
+            <a:ext cx="2281990" cy="523220"/>
+          </a:xfrm>
+          <a:prstGeom prst="rect">
+            <a:avLst/>
+          </a:prstGeom>
+          <a:noFill/>
+        </p:spPr>
+        <p:txBody>
+          <a:bodyPr wrap="square" rtlCol="0">
+            <a:spAutoFit/>
+          </a:bodyPr>
+          <a:lstStyle/>
+          <a:p>
+            <a:r>
+              <a:rPr lang="es-ES" sz="2800" b="1" dirty="0">
+                <a:latin typeface="Libre Franklin" pitchFamily="2" charset="0"/>
+              </a:rPr>
+              <a:t>Pronósticos</a:t>
+            </a:r>
+            <a:endParaRPr lang="es-GT" b="1" dirty="0">
+              <a:latin typeface="Libre Franklin" pitchFamily="2" charset="0"/>
+            </a:endParaRPr>
+          </a:p>
+        </p:txBody>
+      </p:sp>
+      <p:cxnSp>
+        <p:nvCxnSpPr>
+          <p:cNvPr id="8" name="Conector recto 7">
+            <a:extLst>
+              <a:ext uri="{FF2B5EF4-FFF2-40B4-BE49-F238E27FC236}">
+                <a16:creationId xmlns:a16="http://schemas.microsoft.com/office/drawing/2014/main" id="{16C81271-FEEB-0FD9-DC17-5AE6F8772B6E}"/>
+              </a:ext>
+            </a:extLst>
+          </p:cNvPr>
+          <p:cNvCxnSpPr>
+            <a:cxnSpLocks/>
+          </p:cNvCxnSpPr>
+          <p:nvPr/>
+        </p:nvCxnSpPr>
+        <p:spPr>
+          <a:xfrm>
+            <a:off x="265471" y="730459"/>
+            <a:ext cx="2124000" cy="0"/>
+          </a:xfrm>
+          <a:prstGeom prst="line">
+            <a:avLst/>
+          </a:prstGeom>
+          <a:ln w="38100">
+            <a:solidFill>
+              <a:srgbClr val="FF7F00"/>
+            </a:solidFill>
+          </a:ln>
+        </p:spPr>
+        <p:style>
+          <a:lnRef idx="1">
+            <a:schemeClr val="accent1"/>
+          </a:lnRef>
+          <a:fillRef idx="0">
+            <a:schemeClr val="accent1"/>
+          </a:fillRef>
+          <a:effectRef idx="0">
+            <a:schemeClr val="accent1"/>
+          </a:effectRef>
+          <a:fontRef idx="minor">
+            <a:schemeClr val="tx1"/>
+          </a:fontRef>
+        </p:style>
+      </p:cxnSp>
+      <p:pic>
+        <p:nvPicPr>
+          <p:cNvPr id="14" name="Imagen 13">
+            <a:extLst>
+              <a:ext uri="{FF2B5EF4-FFF2-40B4-BE49-F238E27FC236}">
+                <a16:creationId xmlns:a16="http://schemas.microsoft.com/office/drawing/2014/main" id="{3C32DBA2-DB56-47C5-97B1-6FB5A5F4A4C4}"/>
+              </a:ext>
+            </a:extLst>
+          </p:cNvPr>
+          <p:cNvPicPr>
+            <a:picLocks noChangeAspect="1"/>
+          </p:cNvPicPr>
+          <p:nvPr/>
+        </p:nvPicPr>
+        <p:blipFill>
+          <a:blip r:embed="rId2">
+            <a:extLst>
+              <a:ext uri="{28A0092B-C50C-407E-A947-70E740481C1C}">
+                <a14:useLocalDpi xmlns:a14="http://schemas.microsoft.com/office/drawing/2010/main" val="0"/>
+              </a:ext>
+            </a:extLst>
+          </a:blip>
+          <a:stretch>
+            <a:fillRect/>
+          </a:stretch>
+        </p:blipFill>
+        <p:spPr>
+          <a:xfrm>
+            <a:off x="2547461" y="0"/>
+            <a:ext cx="5143500" cy="6858000"/>
+          </a:xfrm>
+          <a:prstGeom prst="rect">
+            <a:avLst/>
+          </a:prstGeom>
+        </p:spPr>
+      </p:pic>
+      <p:sp>
+        <p:nvSpPr>
+          <p:cNvPr id="5" name="CuadroTexto 4">
+            <a:extLst>
+              <a:ext uri="{FF2B5EF4-FFF2-40B4-BE49-F238E27FC236}">
+                <a16:creationId xmlns:a16="http://schemas.microsoft.com/office/drawing/2014/main" id="{CF354A8C-DD79-4F42-8C53-D729E0F9FDDA}"/>
+              </a:ext>
+            </a:extLst>
+          </p:cNvPr>
+          <p:cNvSpPr txBox="1"/>
+          <p:nvPr/>
+        </p:nvSpPr>
+        <p:spPr>
+          <a:xfrm>
+            <a:off x="8027377" y="2857389"/>
+            <a:ext cx="3640015" cy="923330"/>
+          </a:xfrm>
+          <a:prstGeom prst="rect">
+            <a:avLst/>
+          </a:prstGeom>
+          <a:noFill/>
+        </p:spPr>
+        <p:txBody>
+          <a:bodyPr wrap="square" rtlCol="0">
+            <a:spAutoFit/>
+          </a:bodyPr>
+          <a:lstStyle/>
+          <a:p>
+            <a:pPr algn="just"/>
+            <a:r>
+              <a:rPr lang="es-ES" dirty="0"/>
+              <a:t>Pronósticos condicionales a un choque estructural de -1 en la inflación total.</a:t>
+            </a:r>
+          </a:p>
+        </p:txBody>
+      </p:sp>
+    </p:spTree>
+    <p:extLst>
+      <p:ext uri="{BB962C8B-B14F-4D97-AF65-F5344CB8AC3E}">
+        <p14:creationId xmlns:p14="http://schemas.microsoft.com/office/powerpoint/2010/main" val="83734184"/>
+      </p:ext>
+    </p:extLst>
+  </p:cSld>
+  <p:clrMapOvr>
+    <a:masterClrMapping/>
+  </p:clrMapOvr>
+</p:sld>
+</file>
+
+<file path=ppt/slides/slide7.xml><?xml version="1.0" encoding="utf-8"?>
+<p:sld xmlns:a="http://schemas.openxmlformats.org/drawingml/2006/main" xmlns:r="http://schemas.openxmlformats.org/officeDocument/2006/relationships" xmlns:p="http://schemas.openxmlformats.org/presentationml/2006/main">
+  <p:cSld>
+    <p:spTree>
+      <p:nvGrpSpPr>
+        <p:cNvPr id="1" name="">
+          <a:extLst>
+            <a:ext uri="{FF2B5EF4-FFF2-40B4-BE49-F238E27FC236}">
+              <a16:creationId xmlns:a16="http://schemas.microsoft.com/office/drawing/2014/main" id="{54EC1E0F-3A03-65A1-EAA9-2150EE119E83}"/>
+            </a:ext>
+          </a:extLst>
+        </p:cNvPr>
+        <p:cNvGrpSpPr/>
+        <p:nvPr/>
+      </p:nvGrpSpPr>
+      <p:grpSpPr>
+        <a:xfrm>
+          <a:off x="0" y="0"/>
+          <a:ext cx="0" cy="0"/>
+          <a:chOff x="0" y="0"/>
+          <a:chExt cx="0" cy="0"/>
+        </a:xfrm>
+      </p:grpSpPr>
+      <p:pic>
+        <p:nvPicPr>
+          <p:cNvPr id="19" name="Imagen 18">
+            <a:extLst>
+              <a:ext uri="{FF2B5EF4-FFF2-40B4-BE49-F238E27FC236}">
+                <a16:creationId xmlns:a16="http://schemas.microsoft.com/office/drawing/2014/main" id="{EC42B4EE-C38D-4ABD-8FD0-5834A0452150}"/>
+              </a:ext>
+            </a:extLst>
+          </p:cNvPr>
+          <p:cNvPicPr>
+            <a:picLocks noChangeAspect="1"/>
+          </p:cNvPicPr>
+          <p:nvPr/>
+        </p:nvPicPr>
+        <p:blipFill>
+          <a:blip r:embed="rId2">
+            <a:extLst>
+              <a:ext uri="{28A0092B-C50C-407E-A947-70E740481C1C}">
+                <a14:useLocalDpi xmlns:a14="http://schemas.microsoft.com/office/drawing/2010/main" val="0"/>
+              </a:ext>
+            </a:extLst>
+          </a:blip>
+          <a:stretch>
+            <a:fillRect/>
+          </a:stretch>
+        </p:blipFill>
+        <p:spPr>
+          <a:xfrm>
+            <a:off x="0" y="0"/>
+            <a:ext cx="12192000" cy="6858000"/>
+          </a:xfrm>
+          <a:prstGeom prst="rect">
+            <a:avLst/>
+          </a:prstGeom>
+        </p:spPr>
+      </p:pic>
+      <p:sp>
+        <p:nvSpPr>
+          <p:cNvPr id="7" name="CuadroTexto 6">
+            <a:extLst>
+              <a:ext uri="{FF2B5EF4-FFF2-40B4-BE49-F238E27FC236}">
+                <a16:creationId xmlns:a16="http://schemas.microsoft.com/office/drawing/2014/main" id="{ADD180B3-394E-F5B7-5528-22C8C3FB6E23}"/>
+              </a:ext>
+            </a:extLst>
+          </p:cNvPr>
+          <p:cNvSpPr txBox="1"/>
+          <p:nvPr/>
+        </p:nvSpPr>
+        <p:spPr>
+          <a:xfrm>
+            <a:off x="165181" y="207239"/>
+            <a:ext cx="8671087" cy="523220"/>
+          </a:xfrm>
+          <a:prstGeom prst="rect">
+            <a:avLst/>
+          </a:prstGeom>
+          <a:noFill/>
+        </p:spPr>
+        <p:txBody>
+          <a:bodyPr wrap="square" rtlCol="0">
+            <a:spAutoFit/>
+          </a:bodyPr>
+          <a:lstStyle/>
+          <a:p>
+            <a:r>
+              <a:rPr lang="es-ES" sz="2800" b="1" dirty="0">
+                <a:latin typeface="Libre Franklin" pitchFamily="2" charset="0"/>
+              </a:rPr>
+              <a:t>Diferencias con el escenario incondicional </a:t>
+            </a:r>
+            <a:endParaRPr lang="es-GT" b="1" dirty="0">
+              <a:latin typeface="Libre Franklin" pitchFamily="2" charset="0"/>
+            </a:endParaRPr>
+          </a:p>
+        </p:txBody>
+      </p:sp>
+      <p:cxnSp>
+        <p:nvCxnSpPr>
+          <p:cNvPr id="8" name="Conector recto 7">
+            <a:extLst>
+              <a:ext uri="{FF2B5EF4-FFF2-40B4-BE49-F238E27FC236}">
+                <a16:creationId xmlns:a16="http://schemas.microsoft.com/office/drawing/2014/main" id="{16C81271-FEEB-0FD9-DC17-5AE6F8772B6E}"/>
+              </a:ext>
+            </a:extLst>
+          </p:cNvPr>
+          <p:cNvCxnSpPr>
+            <a:cxnSpLocks/>
+          </p:cNvCxnSpPr>
+          <p:nvPr/>
+        </p:nvCxnSpPr>
+        <p:spPr>
+          <a:xfrm>
+            <a:off x="265471" y="730459"/>
+            <a:ext cx="7128000" cy="0"/>
+          </a:xfrm>
+          <a:prstGeom prst="line">
+            <a:avLst/>
+          </a:prstGeom>
+          <a:ln w="38100">
+            <a:solidFill>
+              <a:srgbClr val="FF7F00"/>
+            </a:solidFill>
+          </a:ln>
+        </p:spPr>
+        <p:style>
+          <a:lnRef idx="1">
+            <a:schemeClr val="accent1"/>
+          </a:lnRef>
+          <a:fillRef idx="0">
+            <a:schemeClr val="accent1"/>
+          </a:fillRef>
+          <a:effectRef idx="0">
+            <a:schemeClr val="accent1"/>
+          </a:effectRef>
+          <a:fontRef idx="minor">
+            <a:schemeClr val="tx1"/>
+          </a:fontRef>
+        </p:style>
+      </p:cxnSp>
+      <p:pic>
+        <p:nvPicPr>
+          <p:cNvPr id="18" name="Imagen 17">
+            <a:extLst>
+              <a:ext uri="{FF2B5EF4-FFF2-40B4-BE49-F238E27FC236}">
+                <a16:creationId xmlns:a16="http://schemas.microsoft.com/office/drawing/2014/main" id="{26A9CA35-411C-43A2-8A7D-13CEFD6992DF}"/>
+              </a:ext>
+            </a:extLst>
+          </p:cNvPr>
+          <p:cNvPicPr>
+            <a:picLocks noChangeAspect="1"/>
+          </p:cNvPicPr>
+          <p:nvPr/>
+        </p:nvPicPr>
+        <p:blipFill>
+          <a:blip r:embed="rId3">
+            <a:extLst>
+              <a:ext uri="{28A0092B-C50C-407E-A947-70E740481C1C}">
+                <a14:useLocalDpi xmlns:a14="http://schemas.microsoft.com/office/drawing/2010/main" val="0"/>
+              </a:ext>
+            </a:extLst>
+          </a:blip>
+          <a:stretch>
+            <a:fillRect/>
+          </a:stretch>
+        </p:blipFill>
+        <p:spPr>
+          <a:xfrm>
+            <a:off x="640372" y="937698"/>
+            <a:ext cx="6956181" cy="4637454"/>
+          </a:xfrm>
+          <a:prstGeom prst="rect">
+            <a:avLst/>
+          </a:prstGeom>
+        </p:spPr>
+      </p:pic>
+      <p:sp>
+        <p:nvSpPr>
+          <p:cNvPr id="20" name="CuadroTexto 19">
+            <a:extLst>
+              <a:ext uri="{FF2B5EF4-FFF2-40B4-BE49-F238E27FC236}">
+                <a16:creationId xmlns:a16="http://schemas.microsoft.com/office/drawing/2014/main" id="{1E0EFDE5-B0EF-4A30-906D-670D651CE301}"/>
+              </a:ext>
+            </a:extLst>
+          </p:cNvPr>
+          <p:cNvSpPr txBox="1"/>
+          <p:nvPr/>
+        </p:nvSpPr>
+        <p:spPr>
+          <a:xfrm>
+            <a:off x="7596553" y="1282848"/>
+            <a:ext cx="4035670" cy="1477328"/>
+          </a:xfrm>
+          <a:prstGeom prst="rect">
+            <a:avLst/>
+          </a:prstGeom>
+          <a:noFill/>
+        </p:spPr>
+        <p:txBody>
+          <a:bodyPr wrap="square" rtlCol="0">
+            <a:spAutoFit/>
+          </a:bodyPr>
+          <a:lstStyle/>
+          <a:p>
+            <a:pPr algn="just"/>
+            <a:r>
+              <a:rPr lang="es-ES" dirty="0"/>
+              <a:t>La diferencia Entre el pronóstico condicional e incondicional es marcad al inicio, pero se atenúa con el paso de los periodos hasta estar en valores en torno a 0.35.</a:t>
+            </a:r>
+            <a:endParaRPr lang="es-GT" dirty="0"/>
+          </a:p>
+        </p:txBody>
+      </p:sp>
+    </p:spTree>
+    <p:extLst>
+      <p:ext uri="{BB962C8B-B14F-4D97-AF65-F5344CB8AC3E}">
+        <p14:creationId xmlns:p14="http://schemas.microsoft.com/office/powerpoint/2010/main" val="1766204071"/>
+      </p:ext>
+    </p:extLst>
+  </p:cSld>
+  <p:clrMapOvr>
+    <a:masterClrMapping/>
+  </p:clrMapOvr>
+</p:sld>
+</file>
+
+<file path=ppt/slides/slide8.xml><?xml version="1.0" encoding="utf-8"?>
+<p:sld xmlns:a="http://schemas.openxmlformats.org/drawingml/2006/main" xmlns:r="http://schemas.openxmlformats.org/officeDocument/2006/relationships" xmlns:p="http://schemas.openxmlformats.org/presentationml/2006/main">
+  <p:cSld>
+    <p:spTree>
+      <p:nvGrpSpPr>
+        <p:cNvPr id="1" name="">
+          <a:extLst>
+            <a:ext uri="{FF2B5EF4-FFF2-40B4-BE49-F238E27FC236}">
+              <a16:creationId xmlns:a16="http://schemas.microsoft.com/office/drawing/2014/main" id="{54EC1E0F-3A03-65A1-EAA9-2150EE119E83}"/>
+            </a:ext>
+          </a:extLst>
+        </p:cNvPr>
+        <p:cNvGrpSpPr/>
+        <p:nvPr/>
+      </p:nvGrpSpPr>
+      <p:grpSpPr>
+        <a:xfrm>
+          <a:off x="0" y="0"/>
+          <a:ext cx="0" cy="0"/>
+          <a:chOff x="0" y="0"/>
+          <a:chExt cx="0" cy="0"/>
+        </a:xfrm>
+      </p:grpSpPr>
+      <p:pic>
+        <p:nvPicPr>
+          <p:cNvPr id="19" name="Imagen 18">
+            <a:extLst>
+              <a:ext uri="{FF2B5EF4-FFF2-40B4-BE49-F238E27FC236}">
+                <a16:creationId xmlns:a16="http://schemas.microsoft.com/office/drawing/2014/main" id="{EC42B4EE-C38D-4ABD-8FD0-5834A0452150}"/>
+              </a:ext>
+            </a:extLst>
+          </p:cNvPr>
+          <p:cNvPicPr>
+            <a:picLocks noChangeAspect="1"/>
+          </p:cNvPicPr>
+          <p:nvPr/>
+        </p:nvPicPr>
+        <p:blipFill>
+          <a:blip r:embed="rId2">
+            <a:extLst>
+              <a:ext uri="{28A0092B-C50C-407E-A947-70E740481C1C}">
+                <a14:useLocalDpi xmlns:a14="http://schemas.microsoft.com/office/drawing/2010/main" val="0"/>
+              </a:ext>
+            </a:extLst>
+          </a:blip>
+          <a:stretch>
+            <a:fillRect/>
+          </a:stretch>
+        </p:blipFill>
+        <p:spPr>
+          <a:xfrm>
+            <a:off x="0" y="0"/>
+            <a:ext cx="12192000" cy="6858000"/>
+          </a:xfrm>
+          <a:prstGeom prst="rect">
+            <a:avLst/>
+          </a:prstGeom>
+        </p:spPr>
+      </p:pic>
+      <p:sp>
+        <p:nvSpPr>
+          <p:cNvPr id="7" name="CuadroTexto 6">
+            <a:extLst>
+              <a:ext uri="{FF2B5EF4-FFF2-40B4-BE49-F238E27FC236}">
+                <a16:creationId xmlns:a16="http://schemas.microsoft.com/office/drawing/2014/main" id="{ADD180B3-394E-F5B7-5528-22C8C3FB6E23}"/>
+              </a:ext>
+            </a:extLst>
+          </p:cNvPr>
+          <p:cNvSpPr txBox="1"/>
+          <p:nvPr/>
+        </p:nvSpPr>
+        <p:spPr>
+          <a:xfrm>
+            <a:off x="165181" y="207239"/>
+            <a:ext cx="11264819" cy="523220"/>
+          </a:xfrm>
+          <a:prstGeom prst="rect">
+            <a:avLst/>
+          </a:prstGeom>
+          <a:noFill/>
+        </p:spPr>
+        <p:txBody>
+          <a:bodyPr wrap="square" rtlCol="0">
+            <a:spAutoFit/>
+          </a:bodyPr>
+          <a:lstStyle/>
+          <a:p>
+            <a:r>
+              <a:rPr lang="es-ES" sz="2800" b="1" dirty="0">
+                <a:latin typeface="Libre Franklin" pitchFamily="2" charset="0"/>
+              </a:rPr>
+              <a:t>Coeficiente de sacrificio medido por el crecimiento del producto</a:t>
+            </a:r>
+            <a:endParaRPr lang="es-GT" b="1" dirty="0">
+              <a:latin typeface="Libre Franklin" pitchFamily="2" charset="0"/>
+            </a:endParaRPr>
+          </a:p>
+        </p:txBody>
+      </p:sp>
+      <p:cxnSp>
+        <p:nvCxnSpPr>
+          <p:cNvPr id="8" name="Conector recto 7">
+            <a:extLst>
+              <a:ext uri="{FF2B5EF4-FFF2-40B4-BE49-F238E27FC236}">
+                <a16:creationId xmlns:a16="http://schemas.microsoft.com/office/drawing/2014/main" id="{16C81271-FEEB-0FD9-DC17-5AE6F8772B6E}"/>
+              </a:ext>
+            </a:extLst>
+          </p:cNvPr>
+          <p:cNvCxnSpPr>
+            <a:cxnSpLocks/>
+          </p:cNvCxnSpPr>
+          <p:nvPr/>
+        </p:nvCxnSpPr>
+        <p:spPr>
+          <a:xfrm>
+            <a:off x="265471" y="730459"/>
+            <a:ext cx="10872000" cy="0"/>
+          </a:xfrm>
+          <a:prstGeom prst="line">
+            <a:avLst/>
+          </a:prstGeom>
+          <a:ln w="38100">
+            <a:solidFill>
+              <a:srgbClr val="FF7F00"/>
+            </a:solidFill>
+          </a:ln>
+        </p:spPr>
+        <p:style>
+          <a:lnRef idx="1">
+            <a:schemeClr val="accent1"/>
+          </a:lnRef>
+          <a:fillRef idx="0">
+            <a:schemeClr val="accent1"/>
+          </a:fillRef>
+          <a:effectRef idx="0">
+            <a:schemeClr val="accent1"/>
+          </a:effectRef>
+          <a:fontRef idx="minor">
+            <a:schemeClr val="tx1"/>
+          </a:fontRef>
+        </p:style>
+      </p:cxnSp>
+      <p:sp>
+        <p:nvSpPr>
+          <p:cNvPr id="20" name="CuadroTexto 19">
+            <a:extLst>
+              <a:ext uri="{FF2B5EF4-FFF2-40B4-BE49-F238E27FC236}">
+                <a16:creationId xmlns:a16="http://schemas.microsoft.com/office/drawing/2014/main" id="{1E0EFDE5-B0EF-4A30-906D-670D651CE301}"/>
+              </a:ext>
+            </a:extLst>
+          </p:cNvPr>
+          <p:cNvSpPr txBox="1"/>
+          <p:nvPr/>
+        </p:nvSpPr>
+        <p:spPr>
+          <a:xfrm>
+            <a:off x="7297615" y="2421320"/>
+            <a:ext cx="4035670" cy="1200329"/>
+          </a:xfrm>
+          <a:prstGeom prst="rect">
+            <a:avLst/>
+          </a:prstGeom>
+          <a:noFill/>
+        </p:spPr>
+        <p:txBody>
+          <a:bodyPr wrap="square" rtlCol="0">
+            <a:spAutoFit/>
+          </a:bodyPr>
+          <a:lstStyle/>
+          <a:p>
+            <a:pPr algn="just"/>
+            <a:r>
+              <a:rPr lang="es-ES" dirty="0"/>
+              <a:t>El coeficiente de sacrificio se obtuvo como el área bajo la curva de la diferencia entre el crecimiento del producto y su estado estacionario.</a:t>
+            </a:r>
+          </a:p>
+        </p:txBody>
+      </p:sp>
+      <p:pic>
+        <p:nvPicPr>
+          <p:cNvPr id="5" name="Imagen 4">
+            <a:extLst>
+              <a:ext uri="{FF2B5EF4-FFF2-40B4-BE49-F238E27FC236}">
+                <a16:creationId xmlns:a16="http://schemas.microsoft.com/office/drawing/2014/main" id="{A46A5E28-1043-4BDB-BBEC-227EF12EED52}"/>
+              </a:ext>
+            </a:extLst>
+          </p:cNvPr>
+          <p:cNvPicPr>
+            <a:picLocks noChangeAspect="1"/>
+          </p:cNvPicPr>
+          <p:nvPr/>
+        </p:nvPicPr>
+        <p:blipFill>
+          <a:blip r:embed="rId3">
+            <a:extLst>
+              <a:ext uri="{28A0092B-C50C-407E-A947-70E740481C1C}">
+                <a14:useLocalDpi xmlns:a14="http://schemas.microsoft.com/office/drawing/2010/main" val="0"/>
+              </a:ext>
+            </a:extLst>
+          </a:blip>
+          <a:stretch>
+            <a:fillRect/>
+          </a:stretch>
+        </p:blipFill>
+        <p:spPr>
+          <a:xfrm>
+            <a:off x="482080" y="937698"/>
+            <a:ext cx="6251363" cy="4167575"/>
+          </a:xfrm>
+          <a:prstGeom prst="rect">
+            <a:avLst/>
+          </a:prstGeom>
+        </p:spPr>
+      </p:pic>
+    </p:spTree>
+    <p:extLst>
+      <p:ext uri="{BB962C8B-B14F-4D97-AF65-F5344CB8AC3E}">
+        <p14:creationId xmlns:p14="http://schemas.microsoft.com/office/powerpoint/2010/main" val="1319874067"/>
       </p:ext>
     </p:extLst>
   </p:cSld>

</xml_diff>